<commit_message>
updated labs for ansible and AWS VPC
</commit_message>
<xml_diff>
--- a/1. Kubernetes.pptx
+++ b/1. Kubernetes.pptx
@@ -31072,12 +31072,30 @@
           <a:lstStyle/>
           <a:p>
             <a:r>
-              <a:rPr lang="en-US" sz="1200"/>
+              <a:rPr lang="en-US" sz="1200" dirty="0"/>
               <a:t>https://atul-matkawala-232.github.io/K8s-material/K8s-Replicaset/k8s-rc-replicaset-handson.html</a:t>
             </a:r>
           </a:p>
           <a:p>
+            <a:r>
+              <a:rPr lang="en-US" sz="1200" dirty="0">
+                <a:hlinkClick r:id="rId2"/>
+              </a:rPr>
+              <a:t>https://atul-matkawala-232.github.io/K8s-material/k8s-service/k8s-services-handson.html</a:t>
+            </a:r>
             <a:endParaRPr lang="en-US" sz="1200" dirty="0"/>
+          </a:p>
+          <a:p>
+            <a:r>
+              <a:rPr lang="en-US" sz="1200" dirty="0">
+                <a:hlinkClick r:id="rId3"/>
+              </a:rPr>
+              <a:t>https://atul-matkawala-232.github.io/K8s-material/k8s-voting-app/k8s-voting-app-guide.html</a:t>
+            </a:r>
+            <a:r>
+              <a:rPr lang="en-US" sz="1200" dirty="0"/>
+              <a:t> </a:t>
+            </a:r>
           </a:p>
         </p:txBody>
       </p:sp>

</xml_diff>